<commit_message>
docs: finalize delivery status and ppt team placeholder
</commit_message>
<xml_diff>
--- a/docs/OfficePilot-作品介绍.pptx
+++ b/docs/OfficePilot-作品介绍.pptx
@@ -2040,6 +2040,45 @@
         </p:nvSpPr>
         <p:spPr>
           <a:xfrm>
+            <a:off x="822960" y="5705856"/>
+            <a:ext cx="7315200" cy="237744"/>
+          </a:xfrm>
+          <a:prstGeom prst="rect">
+            <a:avLst/>
+          </a:prstGeom>
+          <a:noFill/>
+          <a:ln/>
+        </p:spPr>
+        <p:txBody>
+          <a:bodyPr wrap="square" lIns="0" tIns="0" rIns="0" bIns="0" rtlCol="0" anchor="ctr"/>
+          <a:lstStyle/>
+          <a:p>
+            <a:pPr indent="0" marL="0">
+              <a:buNone/>
+            </a:pPr>
+            <a:r>
+              <a:rPr lang="en-US" sz="900" dirty="0">
+                <a:solidFill>
+                  <a:srgbClr val="7A7468"/>
+                </a:solidFill>
+                <a:latin typeface="Microsoft YaHei" pitchFamily="34" charset="0"/>
+                <a:ea typeface="Microsoft YaHei" pitchFamily="34" charset="-122"/>
+                <a:cs typeface="Microsoft YaHei" pitchFamily="34" charset="-120"/>
+              </a:rPr>
+              <a:t>团队信息：单人项目 · 姓名：________</a:t>
+            </a:r>
+            <a:endParaRPr lang="en-US" sz="900" dirty="0"/>
+          </a:p>
+        </p:txBody>
+      </p:sp>
+      <p:sp>
+        <p:nvSpPr>
+          <p:cNvPr id="19" name="Text 17"/>
+          <p:cNvSpPr/>
+          <p:nvPr/>
+        </p:nvSpPr>
+        <p:spPr>
+          <a:xfrm>
             <a:off x="822960" y="6053328"/>
             <a:ext cx="9601200" cy="237744"/>
           </a:xfrm>
@@ -2073,7 +2112,7 @@
       </p:sp>
       <p:sp>
         <p:nvSpPr>
-          <p:cNvPr id="19" name="Text 17"/>
+          <p:cNvPr id="20" name="Text 18"/>
           <p:cNvSpPr/>
           <p:nvPr/>
         </p:nvSpPr>
@@ -2101,7 +2140,7 @@
       </p:sp>
       <p:sp>
         <p:nvSpPr>
-          <p:cNvPr id="20" name="Text 18"/>
+          <p:cNvPr id="21" name="Text 19"/>
           <p:cNvSpPr/>
           <p:nvPr/>
         </p:nvSpPr>
@@ -11959,7 +11998,7 @@
                 <a:ea typeface="Microsoft YaHei" pitchFamily="34" charset="-122"/>
                 <a:cs typeface="Microsoft YaHei" pitchFamily="34" charset="-120"/>
               </a:rPr>
-              <a:t>AI-CODING-LOG · 76 个提交与缺陷记录</a:t>
+              <a:t>AI-CODING-LOG · 82 个提交与缺陷记录</a:t>
             </a:r>
             <a:endParaRPr lang="en-US" sz="950" dirty="0"/>
           </a:p>
@@ -12727,7 +12766,7 @@
                 <a:ea typeface="Microsoft YaHei" pitchFamily="34" charset="-122"/>
                 <a:cs typeface="Microsoft YaHei" pitchFamily="34" charset="-120"/>
               </a:rPr>
-              <a:t>演示录屏与现场彩排未完成</a:t>
+              <a:t>现场彩排：E2E 6/6 覆盖主流程；录屏未录制（可选）</a:t>
             </a:r>
             <a:endParaRPr lang="en-US" sz="900" dirty="0"/>
           </a:p>

</xml_diff>